<commit_message>
feat: Complete ChannelTalk removal and system cleanup
- Remove all ChannelTalk integration code and dependencies
- Clean up environment variables and type definitions
- Update documentation to reflect AI system changes
- Consolidate customer support functionality into Triple-AI system

🤖 Generated with [Claude Code](https://claude.ai/code)

Co-Authored-By: Claude <noreply@anthropic.com>
</commit_message>
<xml_diff>
--- a/public/런인베스트/자기주식 컨설팅/자기주식 이익소각(배포용).pptx
+++ b/public/런인베스트/자기주식 컨설팅/자기주식 이익소각(배포용).pptx
@@ -5,7 +5,7 @@
     <p:sldMasterId id="2147483679" r:id="rId1"/>
   </p:sldMasterIdLst>
   <p:notesMasterIdLst>
-    <p:notesMasterId r:id="rId12"/>
+    <p:notesMasterId r:id="rId11"/>
   </p:notesMasterIdLst>
   <p:sldIdLst>
     <p:sldId id="387" r:id="rId2"/>
@@ -17,7 +17,6 @@
     <p:sldId id="399" r:id="rId8"/>
     <p:sldId id="394" r:id="rId9"/>
     <p:sldId id="396" r:id="rId10"/>
-    <p:sldId id="398" r:id="rId11"/>
   </p:sldIdLst>
   <p:sldSz cx="9906000" cy="6858000" type="A4"/>
   <p:notesSz cx="6808788" cy="9942513"/>
@@ -143,13 +142,106 @@
 <file path=ppt/revisionInfo.xml><?xml version="1.0" encoding="utf-8"?>
 <p1510:revInfo xmlns:a="http://schemas.openxmlformats.org/drawingml/2006/main" xmlns:r="http://schemas.openxmlformats.org/officeDocument/2006/relationships" xmlns:p1510="http://schemas.microsoft.com/office/powerpoint/2015/10/main">
   <p1510:revLst>
-    <p1510:client id="{1B5EE24C-4928-45C3-BB2C-08211701B956}" v="1" dt="2023-07-04T08:27:36.695"/>
+    <p1510:client id="{237CC09E-7FDF-4943-A8A5-EF00730B5AB4}" v="4" dt="2024-01-23T06:57:30.104"/>
   </p1510:revLst>
 </p1510:revInfo>
 </file>
 
 <file path=ppt/changesInfos/changesInfo1.xml><?xml version="1.0" encoding="utf-8"?>
 <pc:chgInfo xmlns:a="http://schemas.openxmlformats.org/drawingml/2006/main" xmlns:r="http://schemas.openxmlformats.org/officeDocument/2006/relationships" xmlns:ac="http://schemas.microsoft.com/office/drawing/2013/main/command" xmlns:pc="http://schemas.microsoft.com/office/powerpoint/2013/main/command">
+  <pc:docChgLst>
+    <pc:chgData name="Park sara" userId="256015b203ef4bcb" providerId="LiveId" clId="{237CC09E-7FDF-4943-A8A5-EF00730B5AB4}"/>
+    <pc:docChg chg="custSel delSld modSld">
+      <pc:chgData name="Park sara" userId="256015b203ef4bcb" providerId="LiveId" clId="{237CC09E-7FDF-4943-A8A5-EF00730B5AB4}" dt="2024-01-23T06:57:31.360" v="15" actId="962"/>
+      <pc:docMkLst>
+        <pc:docMk/>
+      </pc:docMkLst>
+      <pc:sldChg chg="addSp delSp modSp mod">
+        <pc:chgData name="Park sara" userId="256015b203ef4bcb" providerId="LiveId" clId="{237CC09E-7FDF-4943-A8A5-EF00730B5AB4}" dt="2024-01-23T06:45:33.588" v="3" actId="962"/>
+        <pc:sldMkLst>
+          <pc:docMk/>
+          <pc:sldMk cId="2107428356" sldId="391"/>
+        </pc:sldMkLst>
+        <pc:picChg chg="del">
+          <ac:chgData name="Park sara" userId="256015b203ef4bcb" providerId="LiveId" clId="{237CC09E-7FDF-4943-A8A5-EF00730B5AB4}" dt="2024-01-23T06:45:29.992" v="0" actId="478"/>
+          <ac:picMkLst>
+            <pc:docMk/>
+            <pc:sldMk cId="2107428356" sldId="391"/>
+            <ac:picMk id="3" creationId="{7F9D58B4-CAF1-F989-0082-A08DEC0FBB35}"/>
+          </ac:picMkLst>
+        </pc:picChg>
+        <pc:picChg chg="add mod">
+          <ac:chgData name="Park sara" userId="256015b203ef4bcb" providerId="LiveId" clId="{237CC09E-7FDF-4943-A8A5-EF00730B5AB4}" dt="2024-01-23T06:45:33.588" v="3" actId="962"/>
+          <ac:picMkLst>
+            <pc:docMk/>
+            <pc:sldMk cId="2107428356" sldId="391"/>
+            <ac:picMk id="5" creationId="{AA10E503-A0C6-42F0-B415-C2DFBE24CE74}"/>
+          </ac:picMkLst>
+        </pc:picChg>
+      </pc:sldChg>
+      <pc:sldChg chg="addSp delSp modSp mod">
+        <pc:chgData name="Park sara" userId="256015b203ef4bcb" providerId="LiveId" clId="{237CC09E-7FDF-4943-A8A5-EF00730B5AB4}" dt="2024-01-23T06:45:40.352" v="6" actId="27614"/>
+        <pc:sldMkLst>
+          <pc:docMk/>
+          <pc:sldMk cId="4015541468" sldId="392"/>
+        </pc:sldMkLst>
+        <pc:picChg chg="add mod">
+          <ac:chgData name="Park sara" userId="256015b203ef4bcb" providerId="LiveId" clId="{237CC09E-7FDF-4943-A8A5-EF00730B5AB4}" dt="2024-01-23T06:45:40.352" v="6" actId="27614"/>
+          <ac:picMkLst>
+            <pc:docMk/>
+            <pc:sldMk cId="4015541468" sldId="392"/>
+            <ac:picMk id="3" creationId="{BA86C328-FD07-4A9E-9BF8-4229FA80A3DF}"/>
+          </ac:picMkLst>
+        </pc:picChg>
+        <pc:picChg chg="del">
+          <ac:chgData name="Park sara" userId="256015b203ef4bcb" providerId="LiveId" clId="{237CC09E-7FDF-4943-A8A5-EF00730B5AB4}" dt="2024-01-23T06:45:35.507" v="4" actId="478"/>
+          <ac:picMkLst>
+            <pc:docMk/>
+            <pc:sldMk cId="4015541468" sldId="392"/>
+            <ac:picMk id="6" creationId="{AC4DEEF9-02C9-4AB2-A905-558592099770}"/>
+          </ac:picMkLst>
+        </pc:picChg>
+      </pc:sldChg>
+      <pc:sldChg chg="addSp delSp modSp mod">
+        <pc:chgData name="Park sara" userId="256015b203ef4bcb" providerId="LiveId" clId="{237CC09E-7FDF-4943-A8A5-EF00730B5AB4}" dt="2024-01-23T06:57:31.360" v="15" actId="962"/>
+        <pc:sldMkLst>
+          <pc:docMk/>
+          <pc:sldMk cId="1099100975" sldId="394"/>
+        </pc:sldMkLst>
+        <pc:picChg chg="add del mod">
+          <ac:chgData name="Park sara" userId="256015b203ef4bcb" providerId="LiveId" clId="{237CC09E-7FDF-4943-A8A5-EF00730B5AB4}" dt="2024-01-23T06:57:27.462" v="12" actId="478"/>
+          <ac:picMkLst>
+            <pc:docMk/>
+            <pc:sldMk cId="1099100975" sldId="394"/>
+            <ac:picMk id="3" creationId="{5B3852DE-F3CA-4403-9BED-39BF9645816F}"/>
+          </ac:picMkLst>
+        </pc:picChg>
+        <pc:picChg chg="add mod">
+          <ac:chgData name="Park sara" userId="256015b203ef4bcb" providerId="LiveId" clId="{237CC09E-7FDF-4943-A8A5-EF00730B5AB4}" dt="2024-01-23T06:57:31.360" v="15" actId="962"/>
+          <ac:picMkLst>
+            <pc:docMk/>
+            <pc:sldMk cId="1099100975" sldId="394"/>
+            <ac:picMk id="5" creationId="{D9E96C9E-FE31-4128-B4D4-ADF5D7D5F9FE}"/>
+          </ac:picMkLst>
+        </pc:picChg>
+        <pc:picChg chg="del">
+          <ac:chgData name="Park sara" userId="256015b203ef4bcb" providerId="LiveId" clId="{237CC09E-7FDF-4943-A8A5-EF00730B5AB4}" dt="2024-01-23T06:45:42.341" v="7" actId="478"/>
+          <ac:picMkLst>
+            <pc:docMk/>
+            <pc:sldMk cId="1099100975" sldId="394"/>
+            <ac:picMk id="6" creationId="{AFCA72DB-F2E4-408A-B761-4597D3DC249F}"/>
+          </ac:picMkLst>
+        </pc:picChg>
+      </pc:sldChg>
+      <pc:sldChg chg="del">
+        <pc:chgData name="Park sara" userId="256015b203ef4bcb" providerId="LiveId" clId="{237CC09E-7FDF-4943-A8A5-EF00730B5AB4}" dt="2024-01-23T06:45:54.923" v="11" actId="2696"/>
+        <pc:sldMkLst>
+          <pc:docMk/>
+          <pc:sldMk cId="2222080259" sldId="398"/>
+        </pc:sldMkLst>
+      </pc:sldChg>
+    </pc:docChg>
+  </pc:docChgLst>
   <pc:docChgLst>
     <pc:chgData name="Park sara" userId="256015b203ef4bcb" providerId="LiveId" clId="{42EFECAB-2EE0-452A-B204-1E6B50D7225D}"/>
     <pc:docChg chg="custSel addSld delSld modSld">
@@ -328,7 +420,7 @@
           <a:p>
             <a:fld id="{D0880E46-7273-814D-999D-097F9042F334}" type="datetimeFigureOut">
               <a:rPr lang="en-US" smtClean="0"/>
-              <a:t>7/4/2023</a:t>
+              <a:t>1/23/2024</a:t>
             </a:fld>
             <a:endParaRPr lang="en-US"/>
           </a:p>
@@ -1417,96 +1509,6 @@
 </p:sld>
 </file>
 
-<file path=ppt/slides/slide10.xml><?xml version="1.0" encoding="utf-8"?>
-<p:sld xmlns:a="http://schemas.openxmlformats.org/drawingml/2006/main" xmlns:r="http://schemas.openxmlformats.org/officeDocument/2006/relationships" xmlns:p="http://schemas.openxmlformats.org/presentationml/2006/main">
-  <p:cSld>
-    <p:spTree>
-      <p:nvGrpSpPr>
-        <p:cNvPr id="1" name=""/>
-        <p:cNvGrpSpPr/>
-        <p:nvPr/>
-      </p:nvGrpSpPr>
-      <p:grpSpPr>
-        <a:xfrm>
-          <a:off x="0" y="0"/>
-          <a:ext cx="0" cy="0"/>
-          <a:chOff x="0" y="0"/>
-          <a:chExt cx="0" cy="0"/>
-        </a:xfrm>
-      </p:grpSpPr>
-      <p:pic>
-        <p:nvPicPr>
-          <p:cNvPr id="6" name="그림 5">
-            <a:extLst>
-              <a:ext uri="{FF2B5EF4-FFF2-40B4-BE49-F238E27FC236}">
-                <a16:creationId xmlns:a16="http://schemas.microsoft.com/office/drawing/2014/main" id="{8372E3B4-49EE-41D5-AA0E-2BE98B502981}"/>
-              </a:ext>
-            </a:extLst>
-          </p:cNvPr>
-          <p:cNvPicPr>
-            <a:picLocks noChangeAspect="1"/>
-          </p:cNvPicPr>
-          <p:nvPr/>
-        </p:nvPicPr>
-        <p:blipFill>
-          <a:blip r:embed="rId2"/>
-          <a:stretch>
-            <a:fillRect/>
-          </a:stretch>
-        </p:blipFill>
-        <p:spPr>
-          <a:xfrm>
-            <a:off x="0" y="0"/>
-            <a:ext cx="9906000" cy="6858000"/>
-          </a:xfrm>
-          <a:prstGeom prst="rect">
-            <a:avLst/>
-          </a:prstGeom>
-        </p:spPr>
-      </p:pic>
-      <p:sp>
-        <p:nvSpPr>
-          <p:cNvPr id="4" name="슬라이드 번호 개체 틀 3">
-            <a:extLst>
-              <a:ext uri="{FF2B5EF4-FFF2-40B4-BE49-F238E27FC236}">
-                <a16:creationId xmlns:a16="http://schemas.microsoft.com/office/drawing/2014/main" id="{6D015898-A48D-48F2-8436-FDB9DD345A57}"/>
-              </a:ext>
-            </a:extLst>
-          </p:cNvPr>
-          <p:cNvSpPr>
-            <a:spLocks noGrp="1"/>
-          </p:cNvSpPr>
-          <p:nvPr>
-            <p:ph type="sldNum" sz="quarter" idx="12"/>
-          </p:nvPr>
-        </p:nvSpPr>
-        <p:spPr/>
-        <p:txBody>
-          <a:bodyPr/>
-          <a:lstStyle/>
-          <a:p>
-            <a:fld id="{93BB12BC-9D34-4146-A949-3BFCA106621A}" type="slidenum">
-              <a:rPr lang="ko-KR" altLang="en-US" smtClean="0"/>
-              <a:pPr/>
-              <a:t>10</a:t>
-            </a:fld>
-            <a:endParaRPr lang="ko-KR" altLang="en-US"/>
-          </a:p>
-        </p:txBody>
-      </p:sp>
-    </p:spTree>
-    <p:extLst>
-      <p:ext uri="{BB962C8B-B14F-4D97-AF65-F5344CB8AC3E}">
-        <p14:creationId xmlns:p14="http://schemas.microsoft.com/office/powerpoint/2010/main" val="2222080259"/>
-      </p:ext>
-    </p:extLst>
-  </p:cSld>
-  <p:clrMapOvr>
-    <a:masterClrMapping/>
-  </p:clrMapOvr>
-</p:sld>
-</file>
-
 <file path=ppt/slides/slide2.xml><?xml version="1.0" encoding="utf-8"?>
 <p:sld xmlns:a="http://schemas.openxmlformats.org/drawingml/2006/main" xmlns:r="http://schemas.openxmlformats.org/officeDocument/2006/relationships" xmlns:p="http://schemas.openxmlformats.org/presentationml/2006/main">
   <p:cSld>
@@ -1823,10 +1825,10 @@
       </p:sp>
       <p:pic>
         <p:nvPicPr>
-          <p:cNvPr id="3" name="그림 2">
+          <p:cNvPr id="5" name="그림 4" descr="텍스트, 스크린샷, 폰트, 번호이(가) 표시된 사진&#10;&#10;자동 생성된 설명">
             <a:extLst>
               <a:ext uri="{FF2B5EF4-FFF2-40B4-BE49-F238E27FC236}">
-                <a16:creationId xmlns:a16="http://schemas.microsoft.com/office/drawing/2014/main" id="{7F9D58B4-CAF1-F989-0082-A08DEC0FBB35}"/>
+                <a16:creationId xmlns:a16="http://schemas.microsoft.com/office/drawing/2014/main" id="{AA10E503-A0C6-42F0-B415-C2DFBE24CE74}"/>
               </a:ext>
             </a:extLst>
           </p:cNvPr>
@@ -1881,36 +1883,6 @@
           <a:chExt cx="0" cy="0"/>
         </a:xfrm>
       </p:grpSpPr>
-      <p:pic>
-        <p:nvPicPr>
-          <p:cNvPr id="6" name="그림 5">
-            <a:extLst>
-              <a:ext uri="{FF2B5EF4-FFF2-40B4-BE49-F238E27FC236}">
-                <a16:creationId xmlns:a16="http://schemas.microsoft.com/office/drawing/2014/main" id="{AC4DEEF9-02C9-4AB2-A905-558592099770}"/>
-              </a:ext>
-            </a:extLst>
-          </p:cNvPr>
-          <p:cNvPicPr>
-            <a:picLocks noChangeAspect="1"/>
-          </p:cNvPicPr>
-          <p:nvPr/>
-        </p:nvPicPr>
-        <p:blipFill>
-          <a:blip r:embed="rId2"/>
-          <a:stretch>
-            <a:fillRect/>
-          </a:stretch>
-        </p:blipFill>
-        <p:spPr>
-          <a:xfrm>
-            <a:off x="0" y="0"/>
-            <a:ext cx="9906000" cy="6858000"/>
-          </a:xfrm>
-          <a:prstGeom prst="rect">
-            <a:avLst/>
-          </a:prstGeom>
-        </p:spPr>
-      </p:pic>
       <p:sp>
         <p:nvSpPr>
           <p:cNvPr id="4" name="슬라이드 번호 개체 틀 3">
@@ -1941,6 +1913,36 @@
           </a:p>
         </p:txBody>
       </p:sp>
+      <p:pic>
+        <p:nvPicPr>
+          <p:cNvPr id="3" name="그림 2" descr="텍스트, 스크린샷, 폰트, 로고이(가) 표시된 사진&#10;&#10;자동 생성된 설명">
+            <a:extLst>
+              <a:ext uri="{FF2B5EF4-FFF2-40B4-BE49-F238E27FC236}">
+                <a16:creationId xmlns:a16="http://schemas.microsoft.com/office/drawing/2014/main" id="{BA86C328-FD07-4A9E-9BF8-4229FA80A3DF}"/>
+              </a:ext>
+            </a:extLst>
+          </p:cNvPr>
+          <p:cNvPicPr>
+            <a:picLocks noChangeAspect="1"/>
+          </p:cNvPicPr>
+          <p:nvPr/>
+        </p:nvPicPr>
+        <p:blipFill>
+          <a:blip r:embed="rId2"/>
+          <a:stretch>
+            <a:fillRect/>
+          </a:stretch>
+        </p:blipFill>
+        <p:spPr>
+          <a:xfrm>
+            <a:off x="0" y="0"/>
+            <a:ext cx="9906000" cy="6858000"/>
+          </a:xfrm>
+          <a:prstGeom prst="rect">
+            <a:avLst/>
+          </a:prstGeom>
+        </p:spPr>
+      </p:pic>
     </p:spTree>
     <p:extLst>
       <p:ext uri="{BB962C8B-B14F-4D97-AF65-F5344CB8AC3E}">
@@ -2086,36 +2088,6 @@
           <a:chExt cx="0" cy="0"/>
         </a:xfrm>
       </p:grpSpPr>
-      <p:pic>
-        <p:nvPicPr>
-          <p:cNvPr id="6" name="그림 5" descr="텍스트이(가) 표시된 사진&#10;&#10;자동 생성된 설명">
-            <a:extLst>
-              <a:ext uri="{FF2B5EF4-FFF2-40B4-BE49-F238E27FC236}">
-                <a16:creationId xmlns:a16="http://schemas.microsoft.com/office/drawing/2014/main" id="{AFCA72DB-F2E4-408A-B761-4597D3DC249F}"/>
-              </a:ext>
-            </a:extLst>
-          </p:cNvPr>
-          <p:cNvPicPr>
-            <a:picLocks noChangeAspect="1"/>
-          </p:cNvPicPr>
-          <p:nvPr/>
-        </p:nvPicPr>
-        <p:blipFill>
-          <a:blip r:embed="rId2"/>
-          <a:stretch>
-            <a:fillRect/>
-          </a:stretch>
-        </p:blipFill>
-        <p:spPr>
-          <a:xfrm>
-            <a:off x="0" y="0"/>
-            <a:ext cx="9906000" cy="6858000"/>
-          </a:xfrm>
-          <a:prstGeom prst="rect">
-            <a:avLst/>
-          </a:prstGeom>
-        </p:spPr>
-      </p:pic>
       <p:sp>
         <p:nvSpPr>
           <p:cNvPr id="4" name="슬라이드 번호 개체 틀 3">
@@ -2146,6 +2118,36 @@
           </a:p>
         </p:txBody>
       </p:sp>
+      <p:pic>
+        <p:nvPicPr>
+          <p:cNvPr id="5" name="그림 4" descr="텍스트, 인간의 얼굴, 스크린샷, 사람이(가) 표시된 사진&#10;&#10;자동 생성된 설명">
+            <a:extLst>
+              <a:ext uri="{FF2B5EF4-FFF2-40B4-BE49-F238E27FC236}">
+                <a16:creationId xmlns:a16="http://schemas.microsoft.com/office/drawing/2014/main" id="{D9E96C9E-FE31-4128-B4D4-ADF5D7D5F9FE}"/>
+              </a:ext>
+            </a:extLst>
+          </p:cNvPr>
+          <p:cNvPicPr>
+            <a:picLocks noChangeAspect="1"/>
+          </p:cNvPicPr>
+          <p:nvPr/>
+        </p:nvPicPr>
+        <p:blipFill>
+          <a:blip r:embed="rId2"/>
+          <a:stretch>
+            <a:fillRect/>
+          </a:stretch>
+        </p:blipFill>
+        <p:spPr>
+          <a:xfrm>
+            <a:off x="0" y="0"/>
+            <a:ext cx="9906000" cy="6858000"/>
+          </a:xfrm>
+          <a:prstGeom prst="rect">
+            <a:avLst/>
+          </a:prstGeom>
+        </p:spPr>
+      </p:pic>
     </p:spTree>
     <p:extLst>
       <p:ext uri="{BB962C8B-B14F-4D97-AF65-F5344CB8AC3E}">

</xml_diff>